<commit_message>
feat: reorganize PPT templates into template-ppt/, add Thrift Kita landing page
Moves root-level PPT/slide templates into template-ppt/ for clarity, adds the
Thrift Kita toko online landing page module (level-up + standalone result),
and updates SI-Fest Sesi 1 deck and generator.
</commit_message>
<xml_diff>
--- a/seminar-sifest/SI-Fest-2026-Sesi1-SafeFonts.pptx
+++ b/seminar-sifest/SI-Fest-2026-Sesi1-SafeFonts.pptx
@@ -140,7 +140,7 @@
   <p:extLst>
     <p:ext uri="{521415D9-36F7-43E2-AB2F-B90AF26B5E84}">
       <p14:sectionLst xmlns:p14="http://schemas.microsoft.com/office/powerpoint/2010/main">
-        <p14:section name="Pembukaan" id="{d38a486d-1f17-9e5c-f5e0-ec400488ec35}">
+        <p14:section name="Pembukaan" id="{7381348d-ad05-ffbb-70c9-65f55e0acfdd}">
           <p14:sldIdLst>
             <p14:sldId id="256"/>
             <p14:sldId id="257"/>
@@ -149,7 +149,7 @@
             <p14:sldId id="260"/>
           </p14:sldIdLst>
         </p14:section>
-        <p14:section name="Dasar Web" id="{f8ed2950-b85d-15b1-9191-efb51a5afffa}">
+        <p14:section name="Dasar Web" id="{3737bf04-5aca-1d9c-4904-6829f21338f3}">
           <p14:sldIdLst>
             <p14:sldId id="261"/>
             <p14:sldId id="262"/>
@@ -158,7 +158,7 @@
             <p14:sldId id="265"/>
           </p14:sldIdLst>
         </p14:section>
-        <p14:section name="HTML" id="{a7358207-30a8-031c-a2c1-befbca0ad9b5}">
+        <p14:section name="HTML" id="{c8c838dc-09a2-6918-f1ea-aedfaa450271}">
           <p14:sldIdLst>
             <p14:sldId id="266"/>
             <p14:sldId id="267"/>
@@ -169,7 +169,7 @@
             <p14:sldId id="272"/>
           </p14:sldIdLst>
         </p14:section>
-        <p14:section name="CSS" id="{83ef685f-5bfc-89cc-7065-9f15d393fad1}">
+        <p14:section name="CSS" id="{ff02d478-567c-711d-62cb-940f9e6548cd}">
           <p14:sldIdLst>
             <p14:sldId id="273"/>
             <p14:sldId id="274"/>
@@ -182,7 +182,7 @@
             <p14:sldId id="281"/>
           </p14:sldIdLst>
         </p14:section>
-        <p14:section name="Proyek &amp; Publish" id="{3058c073-a8b6-7919-cdf1-11ec83178b05}">
+        <p14:section name="Proyek &amp; Publish" id="{5758b612-291f-70c1-fb16-b93654ff6799}">
           <p14:sldIdLst>
             <p14:sldId id="282"/>
             <p14:sldId id="283"/>
@@ -2875,7 +2875,7 @@
               <a:rPr lang="en-US" dirty="0"/>
               <a:t>WAKTU: 0 menit (opsional, tampilkan saat sprint akhir berjalan)
 NASKAH:
-Buat kalian yang sudah selesai lebih cepat, ini jalur lanjutannya. Di LMS HIMTI ada course Modern Web Landing Page: enam modul, murni HTML dan CSS modern. Kalian akan membuat landing page bergaya startup dengan grid, animasi halus, responsive, dan dark mode. Kerjakan sendiri, satu modul demi satu modul.
+Buat kalian yang sudah selesai lebih cepat, ini jalur lanjutannya. Di LMS HIMTI ada course Modern Web: Toko Online, enam modul, murni HTML dan CSS modern. Kalian akan membuat toko thrift online dengan grid produk, animasi hover, responsive, dark mode, dan tombol beli lewat WhatsApp. Kerjakan sendiri, satu modul demi satu modul.
 AKSI:
 Tampilkan slide ini saat siswa mengerjakan sprint akhir, atau setelah ada yang selesai lebih cepat. Siswa yang belum selesai tetap fokus ke profilnya. Ganti [alamat LMS] dengan alamat LMS yang sebenarnya sebelum acara.
 JEBAKAN UMUM:
@@ -33193,7 +33193,7 @@
                 <a:ea typeface="Calibri" pitchFamily="34" charset="-122"/>
                 <a:cs typeface="Calibri" pitchFamily="34" charset="-120"/>
               </a:rPr>
-              <a:t>Course "Modern Web Landing Page" di LMS HIMTI</a:t>
+              <a:t>Course "Modern Web: Toko Online" di LMS HIMTI</a:t>
             </a:r>
             <a:endParaRPr lang="en-US" sz="1800" dirty="0"/>
           </a:p>
@@ -33300,7 +33300,7 @@
                 <a:ea typeface="Calibri" pitchFamily="34" charset="-122"/>
                 <a:cs typeface="Calibri" pitchFamily="34" charset="-120"/>
               </a:rPr>
-              <a:t>Grid, animasi halus, responsive, dan dark mode</a:t>
+              <a:t>Grid, animasi hover, responsive, dan dark mode</a:t>
             </a:r>
             <a:endParaRPr lang="en-US" sz="1800" dirty="0"/>
           </a:p>
@@ -33407,7 +33407,7 @@
                 <a:ea typeface="Calibri" pitchFamily="34" charset="-122"/>
                 <a:cs typeface="Calibri" pitchFamily="34" charset="-120"/>
               </a:rPr>
-              <a:t>Landing page bergaya startup, lalu kamu publish</a:t>
+              <a:t>Toko thrift online, beli via WhatsApp</a:t>
             </a:r>
             <a:endParaRPr lang="en-US" sz="1800" dirty="0"/>
           </a:p>
@@ -33713,7 +33713,7 @@
                 <a:ea typeface="Calibri" pitchFamily="34" charset="-122"/>
                 <a:cs typeface="Calibri" pitchFamily="34" charset="-120"/>
               </a:rPr>
-              <a:t>codekelas.netlify.app</a:t>
+              <a:t>thriftkita.netlify.app</a:t>
             </a:r>
             <a:endParaRPr lang="en-US" sz="1100" dirty="0"/>
           </a:p>
@@ -33775,7 +33775,7 @@
                 <a:ea typeface="Calibri" pitchFamily="34" charset="-122"/>
                 <a:cs typeface="Calibri" pitchFamily="34" charset="-120"/>
               </a:rPr>
-              <a:t>CodeKelas</a:t>
+              <a:t>ThriftKita</a:t>
             </a:r>
             <a:endParaRPr lang="en-US" sz="1300" dirty="0"/>
           </a:p>
@@ -33789,7 +33789,7 @@
         </p:nvSpPr>
         <p:spPr>
           <a:xfrm>
-            <a:off x="7150608" y="2825496"/>
+            <a:off x="7150608" y="2734056"/>
             <a:ext cx="3986784" cy="822960"/>
           </a:xfrm>
           <a:prstGeom prst="rect">
@@ -33809,7 +33809,7 @@
               <a:buNone/>
             </a:pPr>
             <a:r>
-              <a:rPr lang="en-US" sz="2200" b="1" dirty="0">
+              <a:rPr lang="en-US" sz="2100" b="1" dirty="0">
                 <a:solidFill>
                   <a:srgbClr val="0E1B3D"/>
                 </a:solidFill>
@@ -33817,9 +33817,9 @@
                 <a:ea typeface="Calibri" pitchFamily="34" charset="-122"/>
                 <a:cs typeface="Calibri" pitchFamily="34" charset="-120"/>
               </a:rPr>
-              <a:t>Dari nol sampai punya website sendiri</a:t>
-            </a:r>
-            <a:endParaRPr lang="en-US" sz="2200" dirty="0"/>
+              <a:t>Gaya keren tanpa bikin kantong bolong</a:t>
+            </a:r>
+            <a:endParaRPr lang="en-US" sz="2100" dirty="0"/>
           </a:p>
         </p:txBody>
       </p:sp>
@@ -33831,8 +33831,8 @@
         </p:nvSpPr>
         <p:spPr>
           <a:xfrm>
-            <a:off x="7150608" y="3785616"/>
-            <a:ext cx="1188720" cy="329184"/>
+            <a:off x="7150608" y="3648456"/>
+            <a:ext cx="1371600" cy="329184"/>
           </a:xfrm>
           <a:prstGeom prst="roundRect">
             <a:avLst>
@@ -33840,7 +33840,7 @@
             </a:avLst>
           </a:prstGeom>
           <a:solidFill>
-            <a:srgbClr val="1F4FD8"/>
+            <a:srgbClr val="C2410C"/>
           </a:solidFill>
           <a:ln/>
         </p:spPr>
@@ -33853,8 +33853,8 @@
         </p:nvSpPr>
         <p:spPr>
           <a:xfrm>
-            <a:off x="7150608" y="3785616"/>
-            <a:ext cx="1188720" cy="329184"/>
+            <a:off x="7150608" y="3648456"/>
+            <a:ext cx="1371600" cy="329184"/>
           </a:xfrm>
           <a:prstGeom prst="rect">
             <a:avLst/>
@@ -33873,7 +33873,7 @@
               <a:buNone/>
             </a:pPr>
             <a:r>
-              <a:rPr lang="en-US" sz="1100" b="1" dirty="0">
+              <a:rPr lang="en-US" sz="1000" b="1" dirty="0">
                 <a:solidFill>
                   <a:srgbClr val="FFFFFF"/>
                 </a:solidFill>
@@ -33881,9 +33881,9 @@
                 <a:ea typeface="Calibri" pitchFamily="34" charset="-122"/>
                 <a:cs typeface="Calibri" pitchFamily="34" charset="-120"/>
               </a:rPr>
-              <a:t>Lihat Kelas</a:t>
-            </a:r>
-            <a:endParaRPr lang="en-US" sz="1100" dirty="0"/>
+              <a:t>Belanja Sekarang</a:t>
+            </a:r>
+            <a:endParaRPr lang="en-US" sz="1000" dirty="0"/>
           </a:p>
         </p:txBody>
       </p:sp>
@@ -33895,8 +33895,8 @@
         </p:nvSpPr>
         <p:spPr>
           <a:xfrm>
-            <a:off x="7150608" y="4425696"/>
-            <a:ext cx="1237488" cy="1371600"/>
+            <a:off x="7150608" y="4197096"/>
+            <a:ext cx="1237488" cy="1737360"/>
           </a:xfrm>
           <a:prstGeom prst="roundRect">
             <a:avLst>
@@ -33929,8 +33929,30 @@
         </p:nvSpPr>
         <p:spPr>
           <a:xfrm>
-            <a:off x="7278624" y="4562856"/>
-            <a:ext cx="640080" cy="201168"/>
+            <a:off x="7260336" y="4306824"/>
+            <a:ext cx="1018032" cy="731520"/>
+          </a:xfrm>
+          <a:prstGeom prst="roundRect">
+            <a:avLst>
+              <a:gd name="adj" fmla="val 10000"/>
+            </a:avLst>
+          </a:prstGeom>
+          <a:solidFill>
+            <a:srgbClr val="DCE6FF"/>
+          </a:solidFill>
+          <a:ln/>
+        </p:spPr>
+      </p:sp>
+      <p:sp>
+        <p:nvSpPr>
+          <p:cNvPr id="32" name="Shape 30"/>
+          <p:cNvSpPr/>
+          <p:nvPr/>
+        </p:nvSpPr>
+        <p:spPr>
+          <a:xfrm>
+            <a:off x="7260336" y="5129784"/>
+            <a:ext cx="640080" cy="182880"/>
           </a:xfrm>
           <a:prstGeom prst="roundRect">
             <a:avLst>
@@ -33945,14 +33967,14 @@
       </p:sp>
       <p:sp>
         <p:nvSpPr>
-          <p:cNvPr id="32" name="Shape 30"/>
+          <p:cNvPr id="33" name="Shape 31"/>
           <p:cNvSpPr/>
           <p:nvPr/>
         </p:nvSpPr>
         <p:spPr>
           <a:xfrm>
-            <a:off x="7278624" y="4928616"/>
-            <a:ext cx="981456" cy="64008"/>
+            <a:off x="7260336" y="5404104"/>
+            <a:ext cx="1018032" cy="64008"/>
           </a:xfrm>
           <a:prstGeom prst="rect">
             <a:avLst/>
@@ -33965,34 +33987,14 @@
       </p:sp>
       <p:sp>
         <p:nvSpPr>
-          <p:cNvPr id="33" name="Shape 31"/>
-          <p:cNvSpPr/>
-          <p:nvPr/>
-        </p:nvSpPr>
-        <p:spPr>
-          <a:xfrm>
-            <a:off x="7278624" y="5084064"/>
-            <a:ext cx="588874" cy="64008"/>
-          </a:xfrm>
-          <a:prstGeom prst="rect">
-            <a:avLst/>
-          </a:prstGeom>
-          <a:solidFill>
-            <a:srgbClr val="E3DFD6"/>
-          </a:solidFill>
-          <a:ln/>
-        </p:spPr>
-      </p:sp>
-      <p:sp>
-        <p:nvSpPr>
           <p:cNvPr id="34" name="Shape 32"/>
           <p:cNvSpPr/>
           <p:nvPr/>
         </p:nvSpPr>
         <p:spPr>
           <a:xfrm>
-            <a:off x="7278624" y="5477256"/>
-            <a:ext cx="981456" cy="91440"/>
+            <a:off x="7260336" y="5568696"/>
+            <a:ext cx="1018032" cy="237744"/>
           </a:xfrm>
           <a:prstGeom prst="roundRect">
             <a:avLst>
@@ -34000,7 +34002,7 @@
             </a:avLst>
           </a:prstGeom>
           <a:solidFill>
-            <a:srgbClr val="E3DFD6"/>
+            <a:srgbClr val="C2410C"/>
           </a:solidFill>
           <a:ln/>
         </p:spPr>
@@ -34013,30 +34015,8 @@
         </p:nvSpPr>
         <p:spPr>
           <a:xfrm>
-            <a:off x="7278624" y="5477256"/>
-            <a:ext cx="785165" cy="91440"/>
-          </a:xfrm>
-          <a:prstGeom prst="roundRect">
-            <a:avLst>
-              <a:gd name="adj" fmla="val 50000"/>
-            </a:avLst>
-          </a:prstGeom>
-          <a:solidFill>
-            <a:srgbClr val="1F4FD8"/>
-          </a:solidFill>
-          <a:ln/>
-        </p:spPr>
-      </p:sp>
-      <p:sp>
-        <p:nvSpPr>
-          <p:cNvPr id="36" name="Shape 34"/>
-          <p:cNvSpPr/>
-          <p:nvPr/>
-        </p:nvSpPr>
-        <p:spPr>
-          <a:xfrm>
-            <a:off x="8525256" y="4425696"/>
-            <a:ext cx="1237488" cy="1371600"/>
+            <a:off x="8525256" y="4197096"/>
+            <a:ext cx="1237488" cy="1737360"/>
           </a:xfrm>
           <a:prstGeom prst="roundRect">
             <a:avLst>
@@ -34063,14 +34043,36 @@
       </p:sp>
       <p:sp>
         <p:nvSpPr>
+          <p:cNvPr id="36" name="Shape 34"/>
+          <p:cNvSpPr/>
+          <p:nvPr/>
+        </p:nvSpPr>
+        <p:spPr>
+          <a:xfrm>
+            <a:off x="8634984" y="4306824"/>
+            <a:ext cx="1018032" cy="731520"/>
+          </a:xfrm>
+          <a:prstGeom prst="roundRect">
+            <a:avLst>
+              <a:gd name="adj" fmla="val 10000"/>
+            </a:avLst>
+          </a:prstGeom>
+          <a:solidFill>
+            <a:srgbClr val="E8E0D5"/>
+          </a:solidFill>
+          <a:ln/>
+        </p:spPr>
+      </p:sp>
+      <p:sp>
+        <p:nvSpPr>
           <p:cNvPr id="37" name="Shape 35"/>
           <p:cNvSpPr/>
           <p:nvPr/>
         </p:nvSpPr>
         <p:spPr>
           <a:xfrm>
-            <a:off x="8653272" y="4562856"/>
-            <a:ext cx="640080" cy="201168"/>
+            <a:off x="8634984" y="5129784"/>
+            <a:ext cx="640080" cy="182880"/>
           </a:xfrm>
           <a:prstGeom prst="roundRect">
             <a:avLst>
@@ -34091,8 +34093,8 @@
         </p:nvSpPr>
         <p:spPr>
           <a:xfrm>
-            <a:off x="8653272" y="4928616"/>
-            <a:ext cx="981456" cy="64008"/>
+            <a:off x="8634984" y="5404104"/>
+            <a:ext cx="1018032" cy="64008"/>
           </a:xfrm>
           <a:prstGeom prst="rect">
             <a:avLst/>
@@ -34111,28 +34113,8 @@
         </p:nvSpPr>
         <p:spPr>
           <a:xfrm>
-            <a:off x="8653272" y="5084064"/>
-            <a:ext cx="588874" cy="64008"/>
-          </a:xfrm>
-          <a:prstGeom prst="rect">
-            <a:avLst/>
-          </a:prstGeom>
-          <a:solidFill>
-            <a:srgbClr val="E3DFD6"/>
-          </a:solidFill>
-          <a:ln/>
-        </p:spPr>
-      </p:sp>
-      <p:sp>
-        <p:nvSpPr>
-          <p:cNvPr id="40" name="Shape 38"/>
-          <p:cNvSpPr/>
-          <p:nvPr/>
-        </p:nvSpPr>
-        <p:spPr>
-          <a:xfrm>
-            <a:off x="8653272" y="5477256"/>
-            <a:ext cx="981456" cy="91440"/>
+            <a:off x="8634984" y="5568696"/>
+            <a:ext cx="1018032" cy="237744"/>
           </a:xfrm>
           <a:prstGeom prst="roundRect">
             <a:avLst>
@@ -34140,43 +34122,21 @@
             </a:avLst>
           </a:prstGeom>
           <a:solidFill>
-            <a:srgbClr val="E3DFD6"/>
+            <a:srgbClr val="C2410C"/>
           </a:solidFill>
           <a:ln/>
         </p:spPr>
       </p:sp>
       <p:sp>
         <p:nvSpPr>
-          <p:cNvPr id="41" name="Shape 39"/>
+          <p:cNvPr id="40" name="Shape 38"/>
           <p:cNvSpPr/>
           <p:nvPr/>
         </p:nvSpPr>
         <p:spPr>
           <a:xfrm>
-            <a:off x="8653272" y="5477256"/>
-            <a:ext cx="441655" cy="91440"/>
-          </a:xfrm>
-          <a:prstGeom prst="roundRect">
-            <a:avLst>
-              <a:gd name="adj" fmla="val 50000"/>
-            </a:avLst>
-          </a:prstGeom>
-          <a:solidFill>
-            <a:srgbClr val="1F4FD8"/>
-          </a:solidFill>
-          <a:ln/>
-        </p:spPr>
-      </p:sp>
-      <p:sp>
-        <p:nvSpPr>
-          <p:cNvPr id="42" name="Shape 40"/>
-          <p:cNvSpPr/>
-          <p:nvPr/>
-        </p:nvSpPr>
-        <p:spPr>
-          <a:xfrm>
-            <a:off x="9899904" y="4425696"/>
-            <a:ext cx="1237488" cy="1371600"/>
+            <a:off x="9899904" y="4197096"/>
+            <a:ext cx="1237488" cy="1737360"/>
           </a:xfrm>
           <a:prstGeom prst="roundRect">
             <a:avLst>
@@ -34203,14 +34163,36 @@
       </p:sp>
       <p:sp>
         <p:nvSpPr>
-          <p:cNvPr id="43" name="Shape 41"/>
+          <p:cNvPr id="41" name="Shape 39"/>
           <p:cNvSpPr/>
           <p:nvPr/>
         </p:nvSpPr>
         <p:spPr>
           <a:xfrm>
-            <a:off x="10027920" y="4562856"/>
-            <a:ext cx="640080" cy="201168"/>
+            <a:off x="10009632" y="4306824"/>
+            <a:ext cx="1018032" cy="731520"/>
+          </a:xfrm>
+          <a:prstGeom prst="roundRect">
+            <a:avLst>
+              <a:gd name="adj" fmla="val 10000"/>
+            </a:avLst>
+          </a:prstGeom>
+          <a:solidFill>
+            <a:srgbClr val="FFE3B0"/>
+          </a:solidFill>
+          <a:ln/>
+        </p:spPr>
+      </p:sp>
+      <p:sp>
+        <p:nvSpPr>
+          <p:cNvPr id="42" name="Shape 40"/>
+          <p:cNvSpPr/>
+          <p:nvPr/>
+        </p:nvSpPr>
+        <p:spPr>
+          <a:xfrm>
+            <a:off x="10009632" y="5129784"/>
+            <a:ext cx="640080" cy="182880"/>
           </a:xfrm>
           <a:prstGeom prst="roundRect">
             <a:avLst>
@@ -34225,14 +34207,14 @@
       </p:sp>
       <p:sp>
         <p:nvSpPr>
-          <p:cNvPr id="44" name="Shape 42"/>
+          <p:cNvPr id="43" name="Shape 41"/>
           <p:cNvSpPr/>
           <p:nvPr/>
         </p:nvSpPr>
         <p:spPr>
           <a:xfrm>
-            <a:off x="10027920" y="4928616"/>
-            <a:ext cx="981456" cy="64008"/>
+            <a:off x="10009632" y="5404104"/>
+            <a:ext cx="1018032" cy="64008"/>
           </a:xfrm>
           <a:prstGeom prst="rect">
             <a:avLst/>
@@ -34245,34 +34227,14 @@
       </p:sp>
       <p:sp>
         <p:nvSpPr>
-          <p:cNvPr id="45" name="Shape 43"/>
+          <p:cNvPr id="44" name="Shape 42"/>
           <p:cNvSpPr/>
           <p:nvPr/>
         </p:nvSpPr>
         <p:spPr>
           <a:xfrm>
-            <a:off x="10027920" y="5084064"/>
-            <a:ext cx="588874" cy="64008"/>
-          </a:xfrm>
-          <a:prstGeom prst="rect">
-            <a:avLst/>
-          </a:prstGeom>
-          <a:solidFill>
-            <a:srgbClr val="E3DFD6"/>
-          </a:solidFill>
-          <a:ln/>
-        </p:spPr>
-      </p:sp>
-      <p:sp>
-        <p:nvSpPr>
-          <p:cNvPr id="46" name="Shape 44"/>
-          <p:cNvSpPr/>
-          <p:nvPr/>
-        </p:nvSpPr>
-        <p:spPr>
-          <a:xfrm>
-            <a:off x="10027920" y="5477256"/>
-            <a:ext cx="981456" cy="91440"/>
+            <a:off x="10009632" y="5568696"/>
+            <a:ext cx="1018032" cy="237744"/>
           </a:xfrm>
           <a:prstGeom prst="roundRect">
             <a:avLst>
@@ -34280,29 +34242,7 @@
             </a:avLst>
           </a:prstGeom>
           <a:solidFill>
-            <a:srgbClr val="E3DFD6"/>
-          </a:solidFill>
-          <a:ln/>
-        </p:spPr>
-      </p:sp>
-      <p:sp>
-        <p:nvSpPr>
-          <p:cNvPr id="47" name="Shape 45"/>
-          <p:cNvSpPr/>
-          <p:nvPr/>
-        </p:nvSpPr>
-        <p:spPr>
-          <a:xfrm>
-            <a:off x="10027920" y="5477256"/>
-            <a:ext cx="147218" cy="91440"/>
-          </a:xfrm>
-          <a:prstGeom prst="roundRect">
-            <a:avLst>
-              <a:gd name="adj" fmla="val 50000"/>
-            </a:avLst>
-          </a:prstGeom>
-          <a:solidFill>
-            <a:srgbClr val="1F4FD8"/>
+            <a:srgbClr val="C2410C"/>
           </a:solidFill>
           <a:ln/>
         </p:spPr>

</xml_diff>